<commit_message>
Drop the @Lazy slide from the deck
It was built but never taught in the section, so the slides now match
what the recording actually covers. The `w3-31` step keeps it in the
code for anyone who wants to try it.

Co-Authored-By: Claude Opus 5 <noreply@anthropic.com>
</commit_message>
<xml_diff>
--- a/slides/Week 3 - Slides.pptx
+++ b/slides/Week 3 - Slides.pptx
@@ -33,10 +33,9 @@
     <p:sldId id="281" r:id="rId27"/>
     <p:sldId id="282" r:id="rId28"/>
     <p:sldId id="283" r:id="rId29"/>
-    <p:sldId id="284" r:id="rId30"/>
   </p:sldIdLst>
   <p:notesMasterIdLst>
-    <p:notesMasterId r:id="rId31"/>
+    <p:notesMasterId r:id="rId30"/>
   </p:notesMasterIdLst>
   <p:sldSz cx="12191695" cy="6858000"/>
   <p:notesSz cx="6858000" cy="12191695"/>
@@ -2314,94 +2313,6 @@
             <a:fld id="{F7021451-1387-4CA6-816F-3879F97B5CBC}" type="slidenum">
               <a:rPr lang="en-US"/>
               <a:t>28</a:t>
-            </a:fld>
-            <a:endParaRPr lang="en-US"/>
-          </a:p>
-        </p:txBody>
-      </p:sp>
-    </p:spTree>
-    <p:extLst>
-      <p:ext uri="{BB962C8B-B14F-4D97-AF65-F5344CB8AC3E}">
-        <p14:creationId xmlns:p14="http://schemas.microsoft.com/office/powerpoint/2010/main" val="1024086991"/>
-      </p:ext>
-    </p:extLst>
-  </p:cSld>
-  <p:clrMapOvr>
-    <a:masterClrMapping/>
-  </p:clrMapOvr>
-</p:notes>
-</file>
-
-<file path=ppt/notesSlides/notesSlide29.xml><?xml version="1.0" encoding="utf-8"?>
-<p:notes xmlns:a="http://schemas.openxmlformats.org/drawingml/2006/main" xmlns:r="http://schemas.openxmlformats.org/officeDocument/2006/relationships" xmlns:p="http://schemas.openxmlformats.org/presentationml/2006/main">
-  <p:cSld>
-    <p:spTree>
-      <p:nvGrpSpPr>
-        <p:cNvPr id="1" name=""/>
-        <p:cNvGrpSpPr/>
-        <p:nvPr/>
-      </p:nvGrpSpPr>
-      <p:grpSpPr>
-        <a:xfrm>
-          <a:off x="0" y="0"/>
-          <a:ext cx="0" cy="0"/>
-          <a:chOff x="0" y="0"/>
-          <a:chExt cx="0" cy="0"/>
-        </a:xfrm>
-      </p:grpSpPr>
-      <p:sp>
-        <p:nvSpPr>
-          <p:cNvPr id="2" name="Slide Image Placeholder 1"/>
-          <p:cNvSpPr>
-            <a:spLocks noGrp="1" noRot="1" noChangeAspect="1"/>
-          </p:cNvSpPr>
-          <p:nvPr>
-            <p:ph type="sldImg"/>
-          </p:nvPr>
-        </p:nvSpPr>
-        <p:spPr/>
-      </p:sp>
-      <p:sp>
-        <p:nvSpPr>
-          <p:cNvPr id="3" name="Notes Placeholder 2"/>
-          <p:cNvSpPr>
-            <a:spLocks noGrp="1"/>
-          </p:cNvSpPr>
-          <p:nvPr>
-            <p:ph type="body" idx="1"/>
-          </p:nvPr>
-        </p:nvSpPr>
-        <p:spPr/>
-        <p:txBody>
-          <a:bodyPr/>
-          <a:lstStyle/>
-          <a:p>
-            <a:r>
-              <a:rPr lang="en-US" dirty="0"/>
-              <a:t/>
-            </a:r>
-            <a:endParaRPr lang="en-US" dirty="0"/>
-          </a:p>
-        </p:txBody>
-      </p:sp>
-      <p:sp>
-        <p:nvSpPr>
-          <p:cNvPr id="4" name="Slide Number Placeholder 3"/>
-          <p:cNvSpPr>
-            <a:spLocks noGrp="1"/>
-          </p:cNvSpPr>
-          <p:nvPr>
-            <p:ph type="sldNum" sz="quarter" idx="10"/>
-          </p:nvPr>
-        </p:nvSpPr>
-        <p:spPr/>
-        <p:txBody>
-          <a:bodyPr/>
-          <a:lstStyle/>
-          <a:p>
-            <a:fld id="{F7021451-1387-4CA6-816F-3879F97B5CBC}" type="slidenum">
-              <a:rPr lang="en-US"/>
-              <a:t>29</a:t>
             </a:fld>
             <a:endParaRPr lang="en-US"/>
           </a:p>
@@ -15136,7 +15047,7 @@
                 <a:ea typeface="Space Grotesk" pitchFamily="34" charset="-122"/>
                 <a:cs typeface="Space Grotesk" pitchFamily="34" charset="-120"/>
               </a:rPr>
-              <a:t>Life cycle · Putting it off</a:t>
+              <a:t>Next week</a:t>
             </a:r>
             <a:endParaRPr lang="en-US" sz="1300" dirty="0"/>
           </a:p>
@@ -15150,8 +15061,8 @@
         </p:nvSpPr>
         <p:spPr>
           <a:xfrm>
-            <a:off x="812810" y="1154430"/>
-            <a:ext cx="10566166" cy="335310"/>
+            <a:off x="812810" y="1217889"/>
+            <a:ext cx="10566166" cy="782269"/>
           </a:xfrm>
           <a:prstGeom prst="rect">
             <a:avLst/>
@@ -15165,12 +15076,12 @@
           <a:p>
             <a:pPr algn="l" indent="0" marL="0">
               <a:lnSpc>
-                <a:spcPts val="2600"/>
-              </a:lnSpc>
-              <a:buNone/>
-            </a:pPr>
-            <a:r>
-              <a:rPr lang="en-US" sz="2400" b="1" dirty="0">
+                <a:spcPts val="3100"/>
+              </a:lnSpc>
+              <a:buNone/>
+            </a:pPr>
+            <a:r>
+              <a:rPr lang="en-US" sz="2800" b="1" dirty="0">
                 <a:solidFill>
                   <a:srgbClr val="F7F5F0"/>
                 </a:solidFill>
@@ -15178,26 +15089,9 @@
                 <a:ea typeface="Space Grotesk" pitchFamily="34" charset="-122"/>
                 <a:cs typeface="Space Grotesk" pitchFamily="34" charset="-120"/>
               </a:rPr>
-              <a:t>@Lazy</a:t>
-            </a:r>
-            <a:pPr algn="l" indent="0" marL="0">
-              <a:lnSpc>
-                <a:spcPts val="2600"/>
-              </a:lnSpc>
-              <a:buNone/>
-            </a:pPr>
-            <a:r>
-              <a:rPr lang="en-US" sz="2400" b="1" dirty="0">
-                <a:solidFill>
-                  <a:srgbClr val="F7F5F0"/>
-                </a:solidFill>
-                <a:latin typeface="Space Grotesk" pitchFamily="34" charset="0"/>
-                <a:ea typeface="Space Grotesk" pitchFamily="34" charset="-122"/>
-                <a:cs typeface="Space Grotesk" pitchFamily="34" charset="-120"/>
-              </a:rPr>
-              <a:t>: still a singleton, but wait until someone asks</a:t>
-            </a:r>
-            <a:endParaRPr lang="en-US" sz="2400" dirty="0"/>
+              <a:t>So far we write all of this configuration by hand</a:t>
+            </a:r>
+            <a:endParaRPr lang="en-US" sz="2800" dirty="0"/>
           </a:p>
         </p:txBody>
       </p:sp>
@@ -15209,12 +15103,12 @@
         </p:nvSpPr>
         <p:spPr>
           <a:xfrm>
-            <a:off x="812810" y="1616659"/>
-            <a:ext cx="10566166" cy="1493490"/>
+            <a:off x="812810" y="2190720"/>
+            <a:ext cx="10566166" cy="1234440"/>
           </a:xfrm>
           <a:prstGeom prst="roundRect">
             <a:avLst>
-              <a:gd name="adj" fmla="val 6802"/>
+              <a:gd name="adj" fmla="val 8230"/>
             </a:avLst>
           </a:prstGeom>
           <a:solidFill>
@@ -15236,8 +15130,8 @@
         </p:nvSpPr>
         <p:spPr>
           <a:xfrm>
-            <a:off x="1041410" y="1845259"/>
-            <a:ext cx="10108966" cy="1036290"/>
+            <a:off x="1041410" y="2419320"/>
+            <a:ext cx="10108966" cy="777240"/>
           </a:xfrm>
           <a:prstGeom prst="rect">
             <a:avLst/>
@@ -15264,7 +15158,7 @@
                 <a:ea typeface="JetBrains Mono" pitchFamily="34" charset="-122"/>
                 <a:cs typeface="JetBrains Mono" pitchFamily="34" charset="-120"/>
               </a:rPr>
-              <a:t>--- building the context ---</a:t>
+              <a:t>var context = new AnnotationConfigApplicationContext(AppConfig.class);</a:t>
             </a:r>
             <a:endParaRPr lang="en-US" sz="1200" dirty="0"/>
           </a:p>
@@ -15278,13 +15172,13 @@
             <a:r>
               <a:rPr lang="en-US" sz="1200" dirty="0">
                 <a:solidFill>
-                  <a:srgbClr val="F7F5F0"/>
+                  <a:srgbClr val="8FA8CC"/>
                 </a:solidFill>
                 <a:latin typeface="JetBrains Mono" pitchFamily="34" charset="0"/>
                 <a:ea typeface="JetBrains Mono" pitchFamily="34" charset="-122"/>
                 <a:cs typeface="JetBrains Mono" pitchFamily="34" charset="-120"/>
               </a:rPr>
-              <a:t>--- context ready, I have asked for nothing ---</a:t>
+              <a:t>// a pom with every dependency and every version typed out</a:t>
             </a:r>
             <a:endParaRPr lang="en-US" sz="1200" dirty="0"/>
           </a:p>
@@ -15298,650 +15192,28 @@
             <a:r>
               <a:rPr lang="en-US" sz="1200" dirty="0">
                 <a:solidFill>
-                  <a:srgbClr val="5FBFA6"/>
+                  <a:srgbClr val="8FA8CC"/>
                 </a:solidFill>
                 <a:latin typeface="JetBrains Mono" pitchFamily="34" charset="0"/>
                 <a:ea typeface="JetBrains Mono" pitchFamily="34" charset="-122"/>
                 <a:cs typeface="JetBrains Mono" pitchFamily="34" charset="-120"/>
               </a:rPr>
-              <a:t>TicketPrinter created</a:t>
-            </a:r>
-            <a:pPr algn="l" indent="0" marL="0">
-              <a:lnSpc>
-                <a:spcPts val="2000"/>
-              </a:lnSpc>
-              <a:buNone/>
-            </a:pPr>
-            <a:r>
-              <a:rPr lang="en-US" sz="1200" dirty="0">
-                <a:solidFill>
-                  <a:srgbClr val="8FA8CC"/>
-                </a:solidFill>
-                <a:latin typeface="JetBrains Mono" pitchFamily="34" charset="0"/>
-                <a:ea typeface="JetBrains Mono" pitchFamily="34" charset="-122"/>
-                <a:cs typeface="JetBrains Mono" pitchFamily="34" charset="-120"/>
-              </a:rPr>
-              <a:t> ← only now</a:t>
+              <a:t>// and @ComponentScan telling it where to look</a:t>
             </a:r>
             <a:endParaRPr lang="en-US" sz="1200" dirty="0"/>
           </a:p>
-          <a:p>
-            <a:pPr algn="l" indent="0" marL="0">
-              <a:lnSpc>
-                <a:spcPts val="2000"/>
-              </a:lnSpc>
-              <a:buNone/>
-            </a:pPr>
-            <a:r>
-              <a:rPr lang="en-US" sz="1200" dirty="0">
-                <a:solidFill>
-                  <a:srgbClr val="F7F5F0"/>
-                </a:solidFill>
-                <a:latin typeface="JetBrains Mono" pitchFamily="34" charset="0"/>
-                <a:ea typeface="JetBrains Mono" pitchFamily="34" charset="-122"/>
-                <a:cs typeface="JetBrains Mono" pitchFamily="34" charset="-120"/>
-              </a:rPr>
-              <a:t>--- now I asked ---</a:t>
-            </a:r>
-            <a:endParaRPr lang="en-US" sz="1200" dirty="0"/>
-          </a:p>
-        </p:txBody>
-      </p:sp>
-      <p:sp>
-        <p:nvSpPr>
-          <p:cNvPr id="7" name="Shape 5"/>
-          <p:cNvSpPr/>
-          <p:nvPr/>
-        </p:nvSpPr>
-        <p:spPr>
-          <a:xfrm>
-            <a:off x="812810" y="3237159"/>
-            <a:ext cx="10566166" cy="1772839"/>
-          </a:xfrm>
-          <a:prstGeom prst="roundRect">
-            <a:avLst>
-              <a:gd name="adj" fmla="val 5730"/>
-            </a:avLst>
-          </a:prstGeom>
-          <a:solidFill>
-            <a:srgbClr val="1D3153"/>
-          </a:solidFill>
-          <a:ln w="12700">
-            <a:solidFill>
-              <a:srgbClr val="31486E"/>
-            </a:solidFill>
-            <a:prstDash val="solid"/>
-          </a:ln>
-        </p:spPr>
-      </p:sp>
-      <p:graphicFrame>
-        <p:nvGraphicFramePr>
-          <p:cNvPr id="27" name="Table 0"/>
-          <p:cNvGraphicFramePr>
-            <a:graphicFrameLocks noGrp="1"/>
-          </p:cNvGraphicFramePr>
-          <p:nvPr>
-            <p:extLst>
-              <p:ext uri="{D42A27DB-BD31-4B8C-83A1-F6EECF244321}">
-                <p14:modId xmlns:p14="http://schemas.microsoft.com/office/powerpoint/2010/main" val="1579011935"/>
-              </p:ext>
-            </p:extLst>
-          </p:nvPr>
-        </p:nvGraphicFramePr>
-        <p:xfrm>
-          <a:off x="952439" y="3376879"/>
-          <a:ext cx="10286726" cy="914400"/>
-        </p:xfrm>
-        <a:graphic>
-          <a:graphicData uri="http://schemas.openxmlformats.org/drawingml/2006/table">
-            <a:tbl>
-              <a:tblPr/>
-              <a:tblGrid>
-                <a:gridCol w="3908956"/>
-                <a:gridCol w="6377770"/>
-              </a:tblGrid>
-              <a:tr h="0">
-                <a:tc>
-                  <a:txBody>
-                    <a:bodyPr/>
-                    <a:lstStyle/>
-                    <a:p>
-                      <a:pPr algn="l" indent="0" marL="0">
-                        <a:buNone/>
-                      </a:pPr>
-                      <a:r>
-                        <a:rPr lang="en-US" sz="1400" b="1" dirty="0">
-                          <a:solidFill>
-                            <a:srgbClr val="D4AF52"/>
-                          </a:solidFill>
-                          <a:latin typeface="Space Grotesk" pitchFamily="34" charset="0"/>
-                          <a:ea typeface="Space Grotesk" pitchFamily="34" charset="-122"/>
-                          <a:cs typeface="Space Grotesk" pitchFamily="34" charset="-120"/>
-                        </a:rPr>
-                        <a:t>When do you reach for it?</a:t>
-                      </a:r>
-                      <a:endParaRPr lang="en-US" sz="1400" dirty="0">
-                        <a:latin typeface="Space Grotesk" charset="0"/>
-                        <a:ea typeface="Space Grotesk" charset="0"/>
-                        <a:cs typeface="Space Grotesk" charset="0"/>
-                      </a:endParaRPr>
-                    </a:p>
-                  </a:txBody>
-                  <a:tcPr marL="91440" marR="91440" marT="45720" marB="45720" anchor="ctr">
-                    <a:lnL w="6350" cap="flat" cmpd="sng" algn="ctr">
-                      <a:solidFill>
-                        <a:srgbClr val="31486E"/>
-                      </a:solidFill>
-                      <a:prstDash val="solid"/>
-                      <a:round/>
-                      <a:headEnd type="none" w="med" len="med"/>
-                      <a:tailEnd type="none" w="med" len="med"/>
-                    </a:lnL>
-                    <a:lnR w="6350" cap="flat" cmpd="sng" algn="ctr">
-                      <a:solidFill>
-                        <a:srgbClr val="31486E"/>
-                      </a:solidFill>
-                      <a:prstDash val="solid"/>
-                      <a:round/>
-                      <a:headEnd type="none" w="med" len="med"/>
-                      <a:tailEnd type="none" w="med" len="med"/>
-                    </a:lnR>
-                    <a:lnT w="6350" cap="flat" cmpd="sng" algn="ctr">
-                      <a:solidFill>
-                        <a:srgbClr val="31486E"/>
-                      </a:solidFill>
-                      <a:prstDash val="solid"/>
-                      <a:round/>
-                      <a:headEnd type="none" w="med" len="med"/>
-                      <a:tailEnd type="none" w="med" len="med"/>
-                    </a:lnT>
-                    <a:lnB w="6350" cap="flat" cmpd="sng" algn="ctr">
-                      <a:solidFill>
-                        <a:srgbClr val="31486E"/>
-                      </a:solidFill>
-                      <a:prstDash val="solid"/>
-                      <a:round/>
-                      <a:headEnd type="none" w="med" len="med"/>
-                      <a:tailEnd type="none" w="med" len="med"/>
-                    </a:lnB>
-                  </a:tcPr>
-                </a:tc>
-                <a:tc>
-                  <a:txBody>
-                    <a:bodyPr/>
-                    <a:lstStyle/>
-                    <a:p>
-                      <a:pPr algn="l" indent="0" marL="0">
-                        <a:buNone/>
-                      </a:pPr>
-                      <a:r>
-                        <a:rPr lang="en-US" sz="1400" b="1" dirty="0">
-                          <a:solidFill>
-                            <a:srgbClr val="D4AF52"/>
-                          </a:solidFill>
-                          <a:latin typeface="Space Grotesk" pitchFamily="34" charset="0"/>
-                          <a:ea typeface="Space Grotesk" pitchFamily="34" charset="-122"/>
-                          <a:cs typeface="Space Grotesk" pitchFamily="34" charset="-120"/>
-                        </a:rPr>
-                        <a:t>Example</a:t>
-                      </a:r>
-                      <a:endParaRPr lang="en-US" sz="1400" dirty="0">
-                        <a:latin typeface="Space Grotesk" charset="0"/>
-                        <a:ea typeface="Space Grotesk" charset="0"/>
-                        <a:cs typeface="Space Grotesk" charset="0"/>
-                      </a:endParaRPr>
-                    </a:p>
-                  </a:txBody>
-                  <a:tcPr marL="91440" marR="91440" marT="45720" marB="45720" anchor="ctr">
-                    <a:lnL w="6350" cap="flat" cmpd="sng" algn="ctr">
-                      <a:solidFill>
-                        <a:srgbClr val="31486E"/>
-                      </a:solidFill>
-                      <a:prstDash val="solid"/>
-                      <a:round/>
-                      <a:headEnd type="none" w="med" len="med"/>
-                      <a:tailEnd type="none" w="med" len="med"/>
-                    </a:lnL>
-                    <a:lnR w="6350" cap="flat" cmpd="sng" algn="ctr">
-                      <a:solidFill>
-                        <a:srgbClr val="31486E"/>
-                      </a:solidFill>
-                      <a:prstDash val="solid"/>
-                      <a:round/>
-                      <a:headEnd type="none" w="med" len="med"/>
-                      <a:tailEnd type="none" w="med" len="med"/>
-                    </a:lnR>
-                    <a:lnT w="6350" cap="flat" cmpd="sng" algn="ctr">
-                      <a:solidFill>
-                        <a:srgbClr val="31486E"/>
-                      </a:solidFill>
-                      <a:prstDash val="solid"/>
-                      <a:round/>
-                      <a:headEnd type="none" w="med" len="med"/>
-                      <a:tailEnd type="none" w="med" len="med"/>
-                    </a:lnT>
-                    <a:lnB w="6350" cap="flat" cmpd="sng" algn="ctr">
-                      <a:solidFill>
-                        <a:srgbClr val="31486E"/>
-                      </a:solidFill>
-                      <a:prstDash val="solid"/>
-                      <a:round/>
-                      <a:headEnd type="none" w="med" len="med"/>
-                      <a:tailEnd type="none" w="med" len="med"/>
-                    </a:lnB>
-                  </a:tcPr>
-                </a:tc>
-              </a:tr>
-              <a:tr h="0">
-                <a:tc>
-                  <a:txBody>
-                    <a:bodyPr/>
-                    <a:lstStyle/>
-                    <a:p>
-                      <a:pPr algn="l" indent="0" marL="0">
-                        <a:buNone/>
-                      </a:pPr>
-                      <a:r>
-                        <a:rPr lang="en-US" sz="1400" dirty="0">
-                          <a:solidFill>
-                            <a:srgbClr val="F7F5F0"/>
-                          </a:solidFill>
-                          <a:latin typeface="IBM Plex Sans" pitchFamily="34" charset="0"/>
-                          <a:ea typeface="IBM Plex Sans" pitchFamily="34" charset="-122"/>
-                          <a:cs typeface="IBM Plex Sans" pitchFamily="34" charset="-120"/>
-                        </a:rPr>
-                        <a:t>An expensive bean that is rarely used</a:t>
-                      </a:r>
-                      <a:endParaRPr lang="en-US" sz="1400" dirty="0">
-                        <a:latin typeface="IBM Plex Sans" charset="0"/>
-                        <a:ea typeface="IBM Plex Sans" charset="0"/>
-                        <a:cs typeface="IBM Plex Sans" charset="0"/>
-                      </a:endParaRPr>
-                    </a:p>
-                  </a:txBody>
-                  <a:tcPr marL="91440" marR="91440" marT="45720" marB="45720" anchor="ctr">
-                    <a:lnL w="6350" cap="flat" cmpd="sng" algn="ctr">
-                      <a:solidFill>
-                        <a:srgbClr val="31486E"/>
-                      </a:solidFill>
-                      <a:prstDash val="solid"/>
-                      <a:round/>
-                      <a:headEnd type="none" w="med" len="med"/>
-                      <a:tailEnd type="none" w="med" len="med"/>
-                    </a:lnL>
-                    <a:lnR w="6350" cap="flat" cmpd="sng" algn="ctr">
-                      <a:solidFill>
-                        <a:srgbClr val="31486E"/>
-                      </a:solidFill>
-                      <a:prstDash val="solid"/>
-                      <a:round/>
-                      <a:headEnd type="none" w="med" len="med"/>
-                      <a:tailEnd type="none" w="med" len="med"/>
-                    </a:lnR>
-                    <a:lnT w="6350" cap="flat" cmpd="sng" algn="ctr">
-                      <a:solidFill>
-                        <a:srgbClr val="31486E"/>
-                      </a:solidFill>
-                      <a:prstDash val="solid"/>
-                      <a:round/>
-                      <a:headEnd type="none" w="med" len="med"/>
-                      <a:tailEnd type="none" w="med" len="med"/>
-                    </a:lnT>
-                    <a:lnB w="6350" cap="flat" cmpd="sng" algn="ctr">
-                      <a:solidFill>
-                        <a:srgbClr val="31486E"/>
-                      </a:solidFill>
-                      <a:prstDash val="solid"/>
-                      <a:round/>
-                      <a:headEnd type="none" w="med" len="med"/>
-                      <a:tailEnd type="none" w="med" len="med"/>
-                    </a:lnB>
-                  </a:tcPr>
-                </a:tc>
-                <a:tc>
-                  <a:txBody>
-                    <a:bodyPr/>
-                    <a:lstStyle/>
-                    <a:p>
-                      <a:pPr algn="l" indent="0" marL="0">
-                        <a:buNone/>
-                      </a:pPr>
-                      <a:r>
-                        <a:rPr lang="en-US" sz="1400" dirty="0">
-                          <a:solidFill>
-                            <a:srgbClr val="F7F5F0"/>
-                          </a:solidFill>
-                          <a:latin typeface="IBM Plex Sans" pitchFamily="34" charset="0"/>
-                          <a:ea typeface="IBM Plex Sans" pitchFamily="34" charset="-122"/>
-                          <a:cs typeface="IBM Plex Sans" pitchFamily="34" charset="-120"/>
-                        </a:rPr>
-                        <a:t>a slow external system behind an admin screen</a:t>
-                      </a:r>
-                      <a:endParaRPr lang="en-US" sz="1400" dirty="0">
-                        <a:latin typeface="IBM Plex Sans" charset="0"/>
-                        <a:ea typeface="IBM Plex Sans" charset="0"/>
-                        <a:cs typeface="IBM Plex Sans" charset="0"/>
-                      </a:endParaRPr>
-                    </a:p>
-                  </a:txBody>
-                  <a:tcPr marL="91440" marR="91440" marT="45720" marB="45720" anchor="ctr">
-                    <a:lnL w="6350" cap="flat" cmpd="sng" algn="ctr">
-                      <a:solidFill>
-                        <a:srgbClr val="31486E"/>
-                      </a:solidFill>
-                      <a:prstDash val="solid"/>
-                      <a:round/>
-                      <a:headEnd type="none" w="med" len="med"/>
-                      <a:tailEnd type="none" w="med" len="med"/>
-                    </a:lnL>
-                    <a:lnR w="6350" cap="flat" cmpd="sng" algn="ctr">
-                      <a:solidFill>
-                        <a:srgbClr val="31486E"/>
-                      </a:solidFill>
-                      <a:prstDash val="solid"/>
-                      <a:round/>
-                      <a:headEnd type="none" w="med" len="med"/>
-                      <a:tailEnd type="none" w="med" len="med"/>
-                    </a:lnR>
-                    <a:lnT w="6350" cap="flat" cmpd="sng" algn="ctr">
-                      <a:solidFill>
-                        <a:srgbClr val="31486E"/>
-                      </a:solidFill>
-                      <a:prstDash val="solid"/>
-                      <a:round/>
-                      <a:headEnd type="none" w="med" len="med"/>
-                      <a:tailEnd type="none" w="med" len="med"/>
-                    </a:lnT>
-                    <a:lnB w="6350" cap="flat" cmpd="sng" algn="ctr">
-                      <a:solidFill>
-                        <a:srgbClr val="31486E"/>
-                      </a:solidFill>
-                      <a:prstDash val="solid"/>
-                      <a:round/>
-                      <a:headEnd type="none" w="med" len="med"/>
-                      <a:tailEnd type="none" w="med" len="med"/>
-                    </a:lnB>
-                  </a:tcPr>
-                </a:tc>
-              </a:tr>
-              <a:tr h="0">
-                <a:tc>
-                  <a:txBody>
-                    <a:bodyPr/>
-                    <a:lstStyle/>
-                    <a:p>
-                      <a:pPr algn="l" indent="0" marL="0">
-                        <a:buNone/>
-                      </a:pPr>
-                      <a:r>
-                        <a:rPr lang="en-US" sz="1400" dirty="0">
-                          <a:solidFill>
-                            <a:srgbClr val="F7F5F0"/>
-                          </a:solidFill>
-                          <a:latin typeface="IBM Plex Sans" pitchFamily="34" charset="0"/>
-                          <a:ea typeface="IBM Plex Sans" pitchFamily="34" charset="-122"/>
-                          <a:cs typeface="IBM Plex Sans" pitchFamily="34" charset="-120"/>
-                        </a:rPr>
-                        <a:t>A bean you cannot configure locally</a:t>
-                      </a:r>
-                      <a:endParaRPr lang="en-US" sz="1400" dirty="0">
-                        <a:latin typeface="IBM Plex Sans" charset="0"/>
-                        <a:ea typeface="IBM Plex Sans" charset="0"/>
-                        <a:cs typeface="IBM Plex Sans" charset="0"/>
-                      </a:endParaRPr>
-                    </a:p>
-                  </a:txBody>
-                  <a:tcPr marL="91440" marR="91440" marT="45720" marB="45720" anchor="ctr">
-                    <a:lnL w="6350" cap="flat" cmpd="sng" algn="ctr">
-                      <a:solidFill>
-                        <a:srgbClr val="31486E"/>
-                      </a:solidFill>
-                      <a:prstDash val="solid"/>
-                      <a:round/>
-                      <a:headEnd type="none" w="med" len="med"/>
-                      <a:tailEnd type="none" w="med" len="med"/>
-                    </a:lnL>
-                    <a:lnR w="6350" cap="flat" cmpd="sng" algn="ctr">
-                      <a:solidFill>
-                        <a:srgbClr val="31486E"/>
-                      </a:solidFill>
-                      <a:prstDash val="solid"/>
-                      <a:round/>
-                      <a:headEnd type="none" w="med" len="med"/>
-                      <a:tailEnd type="none" w="med" len="med"/>
-                    </a:lnR>
-                    <a:lnT w="6350" cap="flat" cmpd="sng" algn="ctr">
-                      <a:solidFill>
-                        <a:srgbClr val="31486E"/>
-                      </a:solidFill>
-                      <a:prstDash val="solid"/>
-                      <a:round/>
-                      <a:headEnd type="none" w="med" len="med"/>
-                      <a:tailEnd type="none" w="med" len="med"/>
-                    </a:lnT>
-                    <a:lnB w="6350" cap="flat" cmpd="sng" algn="ctr">
-                      <a:solidFill>
-                        <a:srgbClr val="31486E"/>
-                      </a:solidFill>
-                      <a:prstDash val="solid"/>
-                      <a:round/>
-                      <a:headEnd type="none" w="med" len="med"/>
-                      <a:tailEnd type="none" w="med" len="med"/>
-                    </a:lnB>
-                  </a:tcPr>
-                </a:tc>
-                <a:tc>
-                  <a:txBody>
-                    <a:bodyPr/>
-                    <a:lstStyle/>
-                    <a:p>
-                      <a:pPr algn="l" indent="0" marL="0">
-                        <a:buNone/>
-                      </a:pPr>
-                      <a:r>
-                        <a:rPr lang="en-US" sz="1400" dirty="0">
-                          <a:solidFill>
-                            <a:srgbClr val="F7F5F0"/>
-                          </a:solidFill>
-                          <a:latin typeface="IBM Plex Sans" pitchFamily="34" charset="0"/>
-                          <a:ea typeface="IBM Plex Sans" pitchFamily="34" charset="-122"/>
-                          <a:cs typeface="IBM Plex Sans" pitchFamily="34" charset="-120"/>
-                        </a:rPr>
-                        <a:t>a payments client you do not want blocking your startup</a:t>
-                      </a:r>
-                      <a:endParaRPr lang="en-US" sz="1400" dirty="0">
-                        <a:latin typeface="IBM Plex Sans" charset="0"/>
-                        <a:ea typeface="IBM Plex Sans" charset="0"/>
-                        <a:cs typeface="IBM Plex Sans" charset="0"/>
-                      </a:endParaRPr>
-                    </a:p>
-                  </a:txBody>
-                  <a:tcPr marL="91440" marR="91440" marT="45720" marB="45720" anchor="ctr">
-                    <a:lnL w="6350" cap="flat" cmpd="sng" algn="ctr">
-                      <a:solidFill>
-                        <a:srgbClr val="31486E"/>
-                      </a:solidFill>
-                      <a:prstDash val="solid"/>
-                      <a:round/>
-                      <a:headEnd type="none" w="med" len="med"/>
-                      <a:tailEnd type="none" w="med" len="med"/>
-                    </a:lnL>
-                    <a:lnR w="6350" cap="flat" cmpd="sng" algn="ctr">
-                      <a:solidFill>
-                        <a:srgbClr val="31486E"/>
-                      </a:solidFill>
-                      <a:prstDash val="solid"/>
-                      <a:round/>
-                      <a:headEnd type="none" w="med" len="med"/>
-                      <a:tailEnd type="none" w="med" len="med"/>
-                    </a:lnR>
-                    <a:lnT w="6350" cap="flat" cmpd="sng" algn="ctr">
-                      <a:solidFill>
-                        <a:srgbClr val="31486E"/>
-                      </a:solidFill>
-                      <a:prstDash val="solid"/>
-                      <a:round/>
-                      <a:headEnd type="none" w="med" len="med"/>
-                      <a:tailEnd type="none" w="med" len="med"/>
-                    </a:lnT>
-                    <a:lnB w="6350" cap="flat" cmpd="sng" algn="ctr">
-                      <a:solidFill>
-                        <a:srgbClr val="31486E"/>
-                      </a:solidFill>
-                      <a:prstDash val="solid"/>
-                      <a:round/>
-                      <a:headEnd type="none" w="med" len="med"/>
-                      <a:tailEnd type="none" w="med" len="med"/>
-                    </a:lnB>
-                  </a:tcPr>
-                </a:tc>
-              </a:tr>
-              <a:tr h="0">
-                <a:tc>
-                  <a:txBody>
-                    <a:bodyPr/>
-                    <a:lstStyle/>
-                    <a:p>
-                      <a:pPr algn="l" indent="0" marL="0">
-                        <a:buNone/>
-                      </a:pPr>
-                      <a:r>
-                        <a:rPr lang="en-US" sz="1400" dirty="0">
-                          <a:solidFill>
-                            <a:srgbClr val="F7F5F0"/>
-                          </a:solidFill>
-                          <a:latin typeface="IBM Plex Sans" pitchFamily="34" charset="0"/>
-                          <a:ea typeface="IBM Plex Sans" pitchFamily="34" charset="-122"/>
-                          <a:cs typeface="IBM Plex Sans" pitchFamily="34" charset="-120"/>
-                        </a:rPr>
-                        <a:t>A large application while you develop</a:t>
-                      </a:r>
-                      <a:endParaRPr lang="en-US" sz="1400" dirty="0">
-                        <a:latin typeface="IBM Plex Sans" charset="0"/>
-                        <a:ea typeface="IBM Plex Sans" charset="0"/>
-                        <a:cs typeface="IBM Plex Sans" charset="0"/>
-                      </a:endParaRPr>
-                    </a:p>
-                  </a:txBody>
-                  <a:tcPr marL="91440" marR="91440" marT="45720" marB="45720" anchor="ctr">
-                    <a:lnL w="6350" cap="flat" cmpd="sng" algn="ctr">
-                      <a:solidFill>
-                        <a:srgbClr val="31486E"/>
-                      </a:solidFill>
-                      <a:prstDash val="solid"/>
-                      <a:round/>
-                      <a:headEnd type="none" w="med" len="med"/>
-                      <a:tailEnd type="none" w="med" len="med"/>
-                    </a:lnL>
-                    <a:lnR w="6350" cap="flat" cmpd="sng" algn="ctr">
-                      <a:solidFill>
-                        <a:srgbClr val="31486E"/>
-                      </a:solidFill>
-                      <a:prstDash val="solid"/>
-                      <a:round/>
-                      <a:headEnd type="none" w="med" len="med"/>
-                      <a:tailEnd type="none" w="med" len="med"/>
-                    </a:lnR>
-                    <a:lnT w="6350" cap="flat" cmpd="sng" algn="ctr">
-                      <a:solidFill>
-                        <a:srgbClr val="31486E"/>
-                      </a:solidFill>
-                      <a:prstDash val="solid"/>
-                      <a:round/>
-                      <a:headEnd type="none" w="med" len="med"/>
-                      <a:tailEnd type="none" w="med" len="med"/>
-                    </a:lnT>
-                    <a:lnB w="6350" cap="flat" cmpd="sng" algn="ctr">
-                      <a:solidFill>
-                        <a:srgbClr val="31486E"/>
-                      </a:solidFill>
-                      <a:prstDash val="solid"/>
-                      <a:round/>
-                      <a:headEnd type="none" w="med" len="med"/>
-                      <a:tailEnd type="none" w="med" len="med"/>
-                    </a:lnB>
-                  </a:tcPr>
-                </a:tc>
-                <a:tc>
-                  <a:txBody>
-                    <a:bodyPr/>
-                    <a:lstStyle/>
-                    <a:p>
-                      <a:pPr algn="l" indent="0" marL="0">
-                        <a:buNone/>
-                      </a:pPr>
-                      <a:r>
-                        <a:rPr lang="en-US" sz="1400" dirty="0">
-                          <a:solidFill>
-                            <a:srgbClr val="F7F5F0"/>
-                          </a:solidFill>
-                          <a:latin typeface="IBM Plex Sans" pitchFamily="34" charset="0"/>
-                          <a:ea typeface="IBM Plex Sans" pitchFamily="34" charset="-122"/>
-                          <a:cs typeface="IBM Plex Sans" pitchFamily="34" charset="-120"/>
-                        </a:rPr>
-                        <a:t>shorter startup between runs</a:t>
-                      </a:r>
-                      <a:endParaRPr lang="en-US" sz="1400" dirty="0">
-                        <a:latin typeface="IBM Plex Sans" charset="0"/>
-                        <a:ea typeface="IBM Plex Sans" charset="0"/>
-                        <a:cs typeface="IBM Plex Sans" charset="0"/>
-                      </a:endParaRPr>
-                    </a:p>
-                  </a:txBody>
-                  <a:tcPr marL="91440" marR="91440" marT="45720" marB="45720" anchor="ctr">
-                    <a:lnL w="6350" cap="flat" cmpd="sng" algn="ctr">
-                      <a:solidFill>
-                        <a:srgbClr val="31486E"/>
-                      </a:solidFill>
-                      <a:prstDash val="solid"/>
-                      <a:round/>
-                      <a:headEnd type="none" w="med" len="med"/>
-                      <a:tailEnd type="none" w="med" len="med"/>
-                    </a:lnL>
-                    <a:lnR w="6350" cap="flat" cmpd="sng" algn="ctr">
-                      <a:solidFill>
-                        <a:srgbClr val="31486E"/>
-                      </a:solidFill>
-                      <a:prstDash val="solid"/>
-                      <a:round/>
-                      <a:headEnd type="none" w="med" len="med"/>
-                      <a:tailEnd type="none" w="med" len="med"/>
-                    </a:lnR>
-                    <a:lnT w="6350" cap="flat" cmpd="sng" algn="ctr">
-                      <a:solidFill>
-                        <a:srgbClr val="31486E"/>
-                      </a:solidFill>
-                      <a:prstDash val="solid"/>
-                      <a:round/>
-                      <a:headEnd type="none" w="med" len="med"/>
-                      <a:tailEnd type="none" w="med" len="med"/>
-                    </a:lnT>
-                    <a:lnB w="6350" cap="flat" cmpd="sng" algn="ctr">
-                      <a:solidFill>
-                        <a:srgbClr val="31486E"/>
-                      </a:solidFill>
-                      <a:prstDash val="solid"/>
-                      <a:round/>
-                      <a:headEnd type="none" w="med" len="med"/>
-                      <a:tailEnd type="none" w="med" len="med"/>
-                    </a:lnB>
-                  </a:tcPr>
-                </a:tc>
-              </a:tr>
-            </a:tbl>
-          </a:graphicData>
-        </a:graphic>
-      </p:graphicFrame>
-      <p:sp>
-        <p:nvSpPr>
-          <p:cNvPr id="9" name="Text 6"/>
+        </p:txBody>
+      </p:sp>
+      <p:sp>
+        <p:nvSpPr>
+          <p:cNvPr id="7" name="Text 5"/>
           <p:cNvSpPr txBox="1"/>
           <p:nvPr/>
         </p:nvSpPr>
         <p:spPr>
           <a:xfrm>
-            <a:off x="812810" y="5137008"/>
-            <a:ext cx="10566166" cy="571500"/>
+            <a:off x="812810" y="3615629"/>
+            <a:ext cx="10566166" cy="285750"/>
           </a:xfrm>
           <a:prstGeom prst="rect">
             <a:avLst/>
@@ -15968,7 +15240,7 @@
                 <a:ea typeface="IBM Plex Sans" pitchFamily="34" charset="-122"/>
                 <a:cs typeface="IBM Plex Sans" pitchFamily="34" charset="-120"/>
               </a:rPr>
-              <a:t>🔴 </a:t>
+              <a:t>Next week: </a:t>
             </a:r>
             <a:pPr algn="l" indent="0" marL="0">
               <a:lnSpc>
@@ -15979,13 +15251,13 @@
             <a:r>
               <a:rPr lang="en-US" sz="1500" dirty="0">
                 <a:solidFill>
-                  <a:srgbClr val="E2705A"/>
+                  <a:srgbClr val="5FBFA6"/>
                 </a:solidFill>
                 <a:latin typeface="IBM Plex Sans" pitchFamily="34" charset="0"/>
                 <a:ea typeface="IBM Plex Sans" pitchFamily="34" charset="-122"/>
                 <a:cs typeface="IBM Plex Sans" pitchFamily="34" charset="-120"/>
               </a:rPr>
-              <a:t>But do not make everything lazy.</a:t>
+              <a:t>Spring Boot</a:t>
             </a:r>
             <a:pPr algn="l" indent="0" marL="0">
               <a:lnSpc>
@@ -16002,7 +15274,7 @@
                 <a:ea typeface="IBM Plex Sans" pitchFamily="34" charset="-122"/>
                 <a:cs typeface="IBM Plex Sans" pitchFamily="34" charset="-120"/>
               </a:rPr>
-              <a:t> You want a bad bean to fail at startup, not at two in the morning.</a:t>
+              <a:t>. All of these lines disappear.</a:t>
             </a:r>
             <a:endParaRPr lang="en-US" sz="1500" dirty="0"/>
           </a:p>
@@ -16010,7 +15282,7 @@
       </p:sp>
       <p:sp>
         <p:nvSpPr>
-          <p:cNvPr id="10" name="Text 7"/>
+          <p:cNvPr id="8" name="Text 6"/>
           <p:cNvSpPr txBox="1"/>
           <p:nvPr/>
         </p:nvSpPr>
@@ -16155,7 +15427,7 @@
                 <a:ea typeface="Space Grotesk" pitchFamily="34" charset="-122"/>
                 <a:cs typeface="Space Grotesk" pitchFamily="34" charset="-120"/>
               </a:rPr>
-              <a:t>Next week</a:t>
+              <a:t>In short</a:t>
             </a:r>
             <a:endParaRPr lang="en-US" sz="1300" dirty="0"/>
           </a:p>
@@ -16169,8 +15441,8 @@
         </p:nvSpPr>
         <p:spPr>
           <a:xfrm>
-            <a:off x="812810" y="1217889"/>
-            <a:ext cx="10566166" cy="782269"/>
+            <a:off x="812810" y="1167140"/>
+            <a:ext cx="10566166" cy="391180"/>
           </a:xfrm>
           <a:prstGeom prst="rect">
             <a:avLst/>
@@ -16197,7 +15469,7 @@
                 <a:ea typeface="Space Grotesk" pitchFamily="34" charset="-122"/>
                 <a:cs typeface="Space Grotesk" pitchFamily="34" charset="-120"/>
               </a:rPr>
-              <a:t>So far we write all of this configuration by hand</a:t>
+              <a:t>What we walked away with today</a:t>
             </a:r>
             <a:endParaRPr lang="en-US" sz="2800" dirty="0"/>
           </a:p>
@@ -16211,12 +15483,12 @@
         </p:nvSpPr>
         <p:spPr>
           <a:xfrm>
-            <a:off x="812810" y="2190720"/>
-            <a:ext cx="10566166" cy="1234440"/>
+            <a:off x="812810" y="1697949"/>
+            <a:ext cx="10566166" cy="3665098"/>
           </a:xfrm>
           <a:prstGeom prst="roundRect">
             <a:avLst>
-              <a:gd name="adj" fmla="val 8230"/>
+              <a:gd name="adj" fmla="val 2772"/>
             </a:avLst>
           </a:prstGeom>
           <a:solidFill>
@@ -16230,389 +15502,9 @@
           </a:ln>
         </p:spPr>
       </p:sp>
-      <p:sp>
-        <p:nvSpPr>
-          <p:cNvPr id="6" name="Text 4"/>
-          <p:cNvSpPr txBox="1"/>
-          <p:nvPr/>
-        </p:nvSpPr>
-        <p:spPr>
-          <a:xfrm>
-            <a:off x="1041410" y="2419320"/>
-            <a:ext cx="10108966" cy="777240"/>
-          </a:xfrm>
-          <a:prstGeom prst="rect">
-            <a:avLst/>
-          </a:prstGeom>
-          <a:noFill/>
-          <a:ln/>
-        </p:spPr>
-        <p:txBody>
-          <a:bodyPr wrap="square" lIns="0" tIns="0" rIns="0" bIns="0" rtlCol="0" anchor="t"/>
-          <a:lstStyle/>
-          <a:p>
-            <a:pPr algn="l" indent="0" marL="0">
-              <a:lnSpc>
-                <a:spcPts val="2000"/>
-              </a:lnSpc>
-              <a:buNone/>
-            </a:pPr>
-            <a:r>
-              <a:rPr lang="en-US" sz="1200" dirty="0">
-                <a:solidFill>
-                  <a:srgbClr val="F7F5F0"/>
-                </a:solidFill>
-                <a:latin typeface="JetBrains Mono" pitchFamily="34" charset="0"/>
-                <a:ea typeface="JetBrains Mono" pitchFamily="34" charset="-122"/>
-                <a:cs typeface="JetBrains Mono" pitchFamily="34" charset="-120"/>
-              </a:rPr>
-              <a:t>var context = new AnnotationConfigApplicationContext(AppConfig.class);</a:t>
-            </a:r>
-            <a:endParaRPr lang="en-US" sz="1200" dirty="0"/>
-          </a:p>
-          <a:p>
-            <a:pPr algn="l" indent="0" marL="0">
-              <a:lnSpc>
-                <a:spcPts val="2000"/>
-              </a:lnSpc>
-              <a:buNone/>
-            </a:pPr>
-            <a:r>
-              <a:rPr lang="en-US" sz="1200" dirty="0">
-                <a:solidFill>
-                  <a:srgbClr val="8FA8CC"/>
-                </a:solidFill>
-                <a:latin typeface="JetBrains Mono" pitchFamily="34" charset="0"/>
-                <a:ea typeface="JetBrains Mono" pitchFamily="34" charset="-122"/>
-                <a:cs typeface="JetBrains Mono" pitchFamily="34" charset="-120"/>
-              </a:rPr>
-              <a:t>// a pom with every dependency and every version typed out</a:t>
-            </a:r>
-            <a:endParaRPr lang="en-US" sz="1200" dirty="0"/>
-          </a:p>
-          <a:p>
-            <a:pPr algn="l" indent="0" marL="0">
-              <a:lnSpc>
-                <a:spcPts val="2000"/>
-              </a:lnSpc>
-              <a:buNone/>
-            </a:pPr>
-            <a:r>
-              <a:rPr lang="en-US" sz="1200" dirty="0">
-                <a:solidFill>
-                  <a:srgbClr val="8FA8CC"/>
-                </a:solidFill>
-                <a:latin typeface="JetBrains Mono" pitchFamily="34" charset="0"/>
-                <a:ea typeface="JetBrains Mono" pitchFamily="34" charset="-122"/>
-                <a:cs typeface="JetBrains Mono" pitchFamily="34" charset="-120"/>
-              </a:rPr>
-              <a:t>// and @ComponentScan telling it where to look</a:t>
-            </a:r>
-            <a:endParaRPr lang="en-US" sz="1200" dirty="0"/>
-          </a:p>
-        </p:txBody>
-      </p:sp>
-      <p:sp>
-        <p:nvSpPr>
-          <p:cNvPr id="7" name="Text 5"/>
-          <p:cNvSpPr txBox="1"/>
-          <p:nvPr/>
-        </p:nvSpPr>
-        <p:spPr>
-          <a:xfrm>
-            <a:off x="812810" y="3615629"/>
-            <a:ext cx="10566166" cy="285750"/>
-          </a:xfrm>
-          <a:prstGeom prst="rect">
-            <a:avLst/>
-          </a:prstGeom>
-          <a:noFill/>
-          <a:ln/>
-        </p:spPr>
-        <p:txBody>
-          <a:bodyPr wrap="square" lIns="0" tIns="0" rIns="0" bIns="0" rtlCol="0" anchor="t"/>
-          <a:lstStyle/>
-          <a:p>
-            <a:pPr algn="l" indent="0" marL="0">
-              <a:lnSpc>
-                <a:spcPts val="2300"/>
-              </a:lnSpc>
-              <a:buNone/>
-            </a:pPr>
-            <a:r>
-              <a:rPr lang="en-US" sz="1500" dirty="0">
-                <a:solidFill>
-                  <a:srgbClr val="F7F5F0"/>
-                </a:solidFill>
-                <a:latin typeface="IBM Plex Sans" pitchFamily="34" charset="0"/>
-                <a:ea typeface="IBM Plex Sans" pitchFamily="34" charset="-122"/>
-                <a:cs typeface="IBM Plex Sans" pitchFamily="34" charset="-120"/>
-              </a:rPr>
-              <a:t>Next week: </a:t>
-            </a:r>
-            <a:pPr algn="l" indent="0" marL="0">
-              <a:lnSpc>
-                <a:spcPts val="2300"/>
-              </a:lnSpc>
-              <a:buNone/>
-            </a:pPr>
-            <a:r>
-              <a:rPr lang="en-US" sz="1500" dirty="0">
-                <a:solidFill>
-                  <a:srgbClr val="5FBFA6"/>
-                </a:solidFill>
-                <a:latin typeface="IBM Plex Sans" pitchFamily="34" charset="0"/>
-                <a:ea typeface="IBM Plex Sans" pitchFamily="34" charset="-122"/>
-                <a:cs typeface="IBM Plex Sans" pitchFamily="34" charset="-120"/>
-              </a:rPr>
-              <a:t>Spring Boot</a:t>
-            </a:r>
-            <a:pPr algn="l" indent="0" marL="0">
-              <a:lnSpc>
-                <a:spcPts val="2300"/>
-              </a:lnSpc>
-              <a:buNone/>
-            </a:pPr>
-            <a:r>
-              <a:rPr lang="en-US" sz="1500" dirty="0">
-                <a:solidFill>
-                  <a:srgbClr val="F7F5F0"/>
-                </a:solidFill>
-                <a:latin typeface="IBM Plex Sans" pitchFamily="34" charset="0"/>
-                <a:ea typeface="IBM Plex Sans" pitchFamily="34" charset="-122"/>
-                <a:cs typeface="IBM Plex Sans" pitchFamily="34" charset="-120"/>
-              </a:rPr>
-              <a:t>. All of these lines disappear.</a:t>
-            </a:r>
-            <a:endParaRPr lang="en-US" sz="1500" dirty="0"/>
-          </a:p>
-        </p:txBody>
-      </p:sp>
-      <p:sp>
-        <p:nvSpPr>
-          <p:cNvPr id="8" name="Text 6"/>
-          <p:cNvSpPr txBox="1"/>
-          <p:nvPr/>
-        </p:nvSpPr>
-        <p:spPr>
-          <a:xfrm>
-            <a:off x="812810" y="6253307"/>
-            <a:ext cx="3809939" cy="198150"/>
-          </a:xfrm>
-          <a:prstGeom prst="rect">
-            <a:avLst/>
-          </a:prstGeom>
-          <a:noFill/>
-          <a:ln/>
-        </p:spPr>
-        <p:txBody>
-          <a:bodyPr wrap="square" lIns="0" tIns="0" rIns="0" bIns="0" rtlCol="0" anchor="t"/>
-          <a:lstStyle/>
-          <a:p>
-            <a:pPr algn="l" indent="0" marL="0">
-              <a:lnSpc>
-                <a:spcPts val="1600"/>
-              </a:lnSpc>
-              <a:buNone/>
-            </a:pPr>
-            <a:r>
-              <a:rPr lang="en-US" sz="1200" dirty="0">
-                <a:solidFill>
-                  <a:srgbClr val="8094B4"/>
-                </a:solidFill>
-                <a:latin typeface="IBM Plex Sans" pitchFamily="34" charset="0"/>
-                <a:ea typeface="IBM Plex Sans" pitchFamily="34" charset="-122"/>
-                <a:cs typeface="IBM Plex Sans" pitchFamily="34" charset="-120"/>
-              </a:rPr>
-              <a:t>Java Spring · Week 3 · </a:t>
-            </a:r>
-            <a:pPr algn="l" indent="0" marL="0">
-              <a:lnSpc>
-                <a:spcPts val="1600"/>
-              </a:lnSpc>
-              <a:buNone/>
-            </a:pPr>
-            <a:r>
-              <a:rPr lang="en-US" sz="1200" dirty="0">
-                <a:solidFill>
-                  <a:srgbClr val="8094B4"/>
-                </a:solidFill>
-                <a:latin typeface="IBM Plex Sans" pitchFamily="34" charset="0"/>
-                <a:ea typeface="IBM Plex Sans" pitchFamily="34" charset="-122"/>
-                <a:cs typeface="IBM Plex Sans" pitchFamily="34" charset="-120"/>
-              </a:rPr>
-              <a:t>27</a:t>
-            </a:r>
-            <a:endParaRPr lang="en-US" sz="1200" dirty="0"/>
-          </a:p>
-        </p:txBody>
-      </p:sp>
-    </p:spTree>
-  </p:cSld>
-  <p:clrMapOvr>
-    <a:masterClrMapping/>
-  </p:clrMapOvr>
-</p:sld>
-</file>
-
-<file path=ppt/slides/slide28.xml><?xml version="1.0" encoding="utf-8"?>
-<p:sld xmlns:a="http://schemas.openxmlformats.org/drawingml/2006/main" xmlns:r="http://schemas.openxmlformats.org/officeDocument/2006/relationships" xmlns:p="http://schemas.openxmlformats.org/presentationml/2006/main">
-  <p:cSld name="Slide 28">
-    <p:bg>
-      <p:bgPr>
-        <a:solidFill>
-          <a:srgbClr val="13233F"/>
-        </a:solidFill>
-      </p:bgPr>
-    </p:bg>
-    <p:spTree>
-      <p:nvGrpSpPr>
-        <p:cNvPr id="1" name=""/>
-        <p:cNvGrpSpPr/>
-        <p:nvPr/>
-      </p:nvGrpSpPr>
-      <p:grpSpPr>
-        <a:xfrm>
-          <a:off x="0" y="0"/>
-          <a:ext cx="0" cy="0"/>
-          <a:chOff x="0" y="0"/>
-          <a:chExt cx="0" cy="0"/>
-        </a:xfrm>
-      </p:grpSpPr>
-      <p:sp>
-        <p:nvSpPr>
-          <p:cNvPr id="2" name="Shape 0"/>
-          <p:cNvSpPr/>
-          <p:nvPr/>
-        </p:nvSpPr>
-        <p:spPr>
-          <a:xfrm>
-            <a:off x="0" y="0"/>
-            <a:ext cx="12191695" cy="6857817"/>
-          </a:xfrm>
-          <a:prstGeom prst="rect">
-            <a:avLst/>
-          </a:prstGeom>
-          <a:solidFill>
-            <a:srgbClr val="13233F"/>
-          </a:solidFill>
-          <a:ln/>
-        </p:spPr>
-      </p:sp>
-      <p:sp>
-        <p:nvSpPr>
-          <p:cNvPr id="3" name="Text 1"/>
-          <p:cNvSpPr txBox="1"/>
-          <p:nvPr/>
-        </p:nvSpPr>
-        <p:spPr>
-          <a:xfrm>
-            <a:off x="812810" y="812810"/>
-            <a:ext cx="10566166" cy="214610"/>
-          </a:xfrm>
-          <a:prstGeom prst="rect">
-            <a:avLst/>
-          </a:prstGeom>
-          <a:noFill/>
-          <a:ln/>
-        </p:spPr>
-        <p:txBody>
-          <a:bodyPr wrap="square" lIns="0" tIns="0" rIns="0" bIns="0" rtlCol="0" anchor="t"/>
-          <a:lstStyle/>
-          <a:p>
-            <a:pPr algn="l" indent="0" marL="0">
-              <a:lnSpc>
-                <a:spcPts val="1700"/>
-              </a:lnSpc>
-              <a:buNone/>
-            </a:pPr>
-            <a:r>
-              <a:rPr lang="en-US" sz="1300" dirty="0">
-                <a:solidFill>
-                  <a:srgbClr val="D4AF52"/>
-                </a:solidFill>
-                <a:latin typeface="Space Grotesk" pitchFamily="34" charset="0"/>
-                <a:ea typeface="Space Grotesk" pitchFamily="34" charset="-122"/>
-                <a:cs typeface="Space Grotesk" pitchFamily="34" charset="-120"/>
-              </a:rPr>
-              <a:t>In short</a:t>
-            </a:r>
-            <a:endParaRPr lang="en-US" sz="1300" dirty="0"/>
-          </a:p>
-        </p:txBody>
-      </p:sp>
-      <p:sp>
-        <p:nvSpPr>
-          <p:cNvPr id="4" name="Text 2"/>
-          <p:cNvSpPr txBox="1"/>
-          <p:nvPr/>
-        </p:nvSpPr>
-        <p:spPr>
-          <a:xfrm>
-            <a:off x="812810" y="1167140"/>
-            <a:ext cx="10566166" cy="391180"/>
-          </a:xfrm>
-          <a:prstGeom prst="rect">
-            <a:avLst/>
-          </a:prstGeom>
-          <a:noFill/>
-          <a:ln/>
-        </p:spPr>
-        <p:txBody>
-          <a:bodyPr wrap="square" lIns="0" tIns="0" rIns="0" bIns="0" rtlCol="0" anchor="t"/>
-          <a:lstStyle/>
-          <a:p>
-            <a:pPr algn="l" indent="0" marL="0">
-              <a:lnSpc>
-                <a:spcPts val="3100"/>
-              </a:lnSpc>
-              <a:buNone/>
-            </a:pPr>
-            <a:r>
-              <a:rPr lang="en-US" sz="2800" b="1" dirty="0">
-                <a:solidFill>
-                  <a:srgbClr val="F7F5F0"/>
-                </a:solidFill>
-                <a:latin typeface="Space Grotesk" pitchFamily="34" charset="0"/>
-                <a:ea typeface="Space Grotesk" pitchFamily="34" charset="-122"/>
-                <a:cs typeface="Space Grotesk" pitchFamily="34" charset="-120"/>
-              </a:rPr>
-              <a:t>What we walked away with today</a:t>
-            </a:r>
-            <a:endParaRPr lang="en-US" sz="2800" dirty="0"/>
-          </a:p>
-        </p:txBody>
-      </p:sp>
-      <p:sp>
-        <p:nvSpPr>
-          <p:cNvPr id="5" name="Shape 3"/>
-          <p:cNvSpPr/>
-          <p:nvPr/>
-        </p:nvSpPr>
-        <p:spPr>
-          <a:xfrm>
-            <a:off x="812810" y="1697949"/>
-            <a:ext cx="10566166" cy="3665098"/>
-          </a:xfrm>
-          <a:prstGeom prst="roundRect">
-            <a:avLst>
-              <a:gd name="adj" fmla="val 2772"/>
-            </a:avLst>
-          </a:prstGeom>
-          <a:solidFill>
-            <a:srgbClr val="1D3153"/>
-          </a:solidFill>
-          <a:ln w="12700">
-            <a:solidFill>
-              <a:srgbClr val="31486E"/>
-            </a:solidFill>
-            <a:prstDash val="solid"/>
-          </a:ln>
-        </p:spPr>
-      </p:sp>
       <p:graphicFrame>
         <p:nvGraphicFramePr>
-          <p:cNvPr id="29" name="Table 0"/>
+          <p:cNvPr id="28" name="Table 0"/>
           <p:cNvGraphicFramePr>
             <a:graphicFrameLocks noGrp="1"/>
           </p:cNvGraphicFramePr>
@@ -17870,7 +16762,7 @@
                 <a:ea typeface="IBM Plex Sans" pitchFamily="34" charset="-122"/>
                 <a:cs typeface="IBM Plex Sans" pitchFamily="34" charset="-120"/>
               </a:rPr>
-              <a:t>28</a:t>
+              <a:t>27</a:t>
             </a:r>
             <a:endParaRPr lang="en-US" sz="1200" dirty="0"/>
           </a:p>
@@ -17884,9 +16776,9 @@
 </p:sld>
 </file>
 
-<file path=ppt/slides/slide29.xml><?xml version="1.0" encoding="utf-8"?>
+<file path=ppt/slides/slide28.xml><?xml version="1.0" encoding="utf-8"?>
 <p:sld xmlns:a="http://schemas.openxmlformats.org/drawingml/2006/main" xmlns:r="http://schemas.openxmlformats.org/officeDocument/2006/relationships" xmlns:p="http://schemas.openxmlformats.org/presentationml/2006/main">
-  <p:cSld name="Slide 29">
+  <p:cSld name="Slide 28">
     <p:bg>
       <p:bgPr>
         <a:solidFill>

</xml_diff>